<commit_message>
Update Weekly Report Dashboard presentation
</commit_message>
<xml_diff>
--- a/Weekly_Report_Dashboard_Presentation.pptx
+++ b/Weekly_Report_Dashboard_Presentation.pptx
@@ -2840,7 +2840,7 @@
         </p:nvSpPr>
         <p:spPr>
           <a:xfrm>
-            <a:off x="731520" y="2103120"/>
+            <a:off x="731520" y="1508744"/>
             <a:ext cx="7315200" cy="914400"/>
           </a:xfrm>
           <a:prstGeom prst="rect">
@@ -2879,7 +2879,7 @@
         </p:nvSpPr>
         <p:spPr>
           <a:xfrm>
-            <a:off x="731520" y="2971800"/>
+            <a:off x="731520" y="2223312"/>
             <a:ext cx="9144000" cy="457200"/>
           </a:xfrm>
           <a:prstGeom prst="rect">
@@ -2918,7 +2918,7 @@
         </p:nvSpPr>
         <p:spPr>
           <a:xfrm>
-            <a:off x="1078531" y="4174236"/>
+            <a:off x="1070234" y="5139991"/>
             <a:ext cx="350305" cy="365760"/>
           </a:xfrm>
           <a:prstGeom prst="roundRect">
@@ -2927,7 +2927,7 @@
             </a:avLst>
           </a:prstGeom>
           <a:solidFill>
-            <a:srgbClr val="92D050"/>
+            <a:srgbClr val="FFC000"/>
           </a:solidFill>
           <a:ln/>
         </p:spPr>
@@ -2940,8 +2940,8 @@
         </p:nvSpPr>
         <p:spPr>
           <a:xfrm>
-            <a:off x="1474631" y="4197096"/>
-            <a:ext cx="7315200" cy="502920"/>
+            <a:off x="1474630" y="4197096"/>
+            <a:ext cx="8124923" cy="502920"/>
           </a:xfrm>
           <a:prstGeom prst="rect">
             <a:avLst/>
@@ -3111,6 +3111,48 @@
               </a:solidFill>
             </a:endParaRPr>
           </a:p>
+          <a:p>
+            <a:r>
+              <a:rPr lang="en-US" sz="1300" dirty="0" smtClean="0">
+                <a:solidFill>
+                  <a:schemeClr val="bg1"/>
+                </a:solidFill>
+              </a:rPr>
+              <a:t>Presentation Link </a:t>
+            </a:r>
+          </a:p>
+          <a:p>
+            <a:r>
+              <a:rPr lang="en-US" sz="1300" dirty="0">
+                <a:solidFill>
+                  <a:schemeClr val="bg1"/>
+                </a:solidFill>
+                <a:hlinkClick r:id="rId6"/>
+              </a:rPr>
+              <a:t>https://docs.google.com/presentation/d/18cRkAIfj8Ec4Jplj7lTexhhIY264SNo-/</a:t>
+            </a:r>
+            <a:r>
+              <a:rPr lang="en-US" sz="1300" dirty="0" smtClean="0">
+                <a:solidFill>
+                  <a:schemeClr val="bg1"/>
+                </a:solidFill>
+                <a:hlinkClick r:id="rId6"/>
+              </a:rPr>
+              <a:t>edit?usp=sharing&amp;ouid=118075605909374359343&amp;rtpof=true&amp;sd=true</a:t>
+            </a:r>
+            <a:endParaRPr lang="en-US" sz="1300" dirty="0" smtClean="0">
+              <a:solidFill>
+                <a:schemeClr val="bg1"/>
+              </a:solidFill>
+            </a:endParaRPr>
+          </a:p>
+          <a:p>
+            <a:endParaRPr lang="en-US" sz="1300" dirty="0">
+              <a:solidFill>
+                <a:schemeClr val="bg1"/>
+              </a:solidFill>
+            </a:endParaRPr>
+          </a:p>
         </p:txBody>
       </p:sp>
       <p:sp>
@@ -3200,14 +3242,14 @@
           <p:nvPr/>
         </p:nvPicPr>
         <p:blipFill>
-          <a:blip r:embed="rId6"/>
+          <a:blip r:embed="rId7"/>
           <a:stretch>
             <a:fillRect/>
           </a:stretch>
         </p:blipFill>
         <p:spPr>
           <a:xfrm>
-            <a:off x="1078531" y="3520408"/>
+            <a:off x="1075237" y="3091719"/>
             <a:ext cx="353599" cy="365792"/>
           </a:xfrm>
           <a:prstGeom prst="rect">
@@ -3224,14 +3266,38 @@
           <p:nvPr/>
         </p:nvPicPr>
         <p:blipFill>
-          <a:blip r:embed="rId7"/>
+          <a:blip r:embed="rId8"/>
           <a:stretch>
             <a:fillRect/>
           </a:stretch>
         </p:blipFill>
         <p:spPr>
           <a:xfrm>
-            <a:off x="1076883" y="4814284"/>
+            <a:off x="1075236" y="4425680"/>
+            <a:ext cx="353599" cy="365792"/>
+          </a:xfrm>
+          <a:prstGeom prst="rect">
+            <a:avLst/>
+          </a:prstGeom>
+        </p:spPr>
+      </p:pic>
+      <p:pic>
+        <p:nvPicPr>
+          <p:cNvPr id="15" name="Picture 14"/>
+          <p:cNvPicPr>
+            <a:picLocks noChangeAspect="1"/>
+          </p:cNvPicPr>
+          <p:nvPr/>
+        </p:nvPicPr>
+        <p:blipFill>
+          <a:blip r:embed="rId9"/>
+          <a:stretch>
+            <a:fillRect/>
+          </a:stretch>
+        </p:blipFill>
+        <p:spPr>
+          <a:xfrm>
+            <a:off x="1075237" y="3705791"/>
             <a:ext cx="353599" cy="365792"/>
           </a:xfrm>
           <a:prstGeom prst="rect">

</xml_diff>